<commit_message>
Publish v6 with Swiss grid layout for slide 7
</commit_message>
<xml_diff>
--- a/slides/slide-07.pptx
+++ b/slides/slide-07.pptx
@@ -4373,8 +4373,8 @@
         </p:nvSpPr>
         <p:spPr>
           <a:xfrm xmlns:a="http://schemas.openxmlformats.org/drawingml/2006/main">
-            <a:off x="609480" y="514440"/>
-            <a:ext cx="3333240" cy="313920"/>
+            <a:off x="609600" y="609600"/>
+            <a:ext cx="4438650" cy="304800"/>
           </a:xfrm>
           <a:prstGeom xmlns:a="http://schemas.openxmlformats.org/drawingml/2006/main" prst="rect">
             <a:avLst/>
@@ -4395,80 +4395,80 @@
             <a:noAutofit/>
           </a:bodyPr>
           <a:lstStyle xmlns:a="http://schemas.openxmlformats.org/drawingml/2006/main">
-            <a:defPPr>
-              <a:defRPr>
+            <a:defPPr algn="l">
+              <a:defRPr sz="1500">
                 <a:latin typeface="HarmonyOS Sans SC"/>
                 <a:ea typeface="HarmonyOS Sans SC"/>
                 <a:cs typeface="HarmonyOS Sans SC"/>
               </a:defRPr>
             </a:defPPr>
-            <a:lvl1pPr>
-              <a:buNone/>
-              <a:defRPr>
+            <a:lvl1pPr algn="l">
+              <a:buNone/>
+              <a:defRPr sz="1500">
                 <a:latin typeface="HarmonyOS Sans SC"/>
                 <a:ea typeface="HarmonyOS Sans SC"/>
                 <a:cs typeface="HarmonyOS Sans SC"/>
               </a:defRPr>
             </a:lvl1pPr>
-            <a:lvl2pPr>
-              <a:buNone/>
-              <a:defRPr>
+            <a:lvl2pPr algn="l">
+              <a:buNone/>
+              <a:defRPr sz="1500">
                 <a:latin typeface="HarmonyOS Sans SC"/>
                 <a:ea typeface="HarmonyOS Sans SC"/>
                 <a:cs typeface="HarmonyOS Sans SC"/>
               </a:defRPr>
             </a:lvl2pPr>
-            <a:lvl3pPr>
-              <a:buNone/>
-              <a:defRPr>
+            <a:lvl3pPr algn="l">
+              <a:buNone/>
+              <a:defRPr sz="1500">
                 <a:latin typeface="HarmonyOS Sans SC"/>
                 <a:ea typeface="HarmonyOS Sans SC"/>
                 <a:cs typeface="HarmonyOS Sans SC"/>
               </a:defRPr>
             </a:lvl3pPr>
-            <a:lvl4pPr>
-              <a:buNone/>
-              <a:defRPr>
+            <a:lvl4pPr algn="l">
+              <a:buNone/>
+              <a:defRPr sz="1500">
                 <a:latin typeface="HarmonyOS Sans SC"/>
                 <a:ea typeface="HarmonyOS Sans SC"/>
                 <a:cs typeface="HarmonyOS Sans SC"/>
               </a:defRPr>
             </a:lvl4pPr>
-            <a:lvl5pPr>
-              <a:buNone/>
-              <a:defRPr>
+            <a:lvl5pPr algn="l">
+              <a:buNone/>
+              <a:defRPr sz="1500">
                 <a:latin typeface="HarmonyOS Sans SC"/>
                 <a:ea typeface="HarmonyOS Sans SC"/>
                 <a:cs typeface="HarmonyOS Sans SC"/>
               </a:defRPr>
             </a:lvl5pPr>
-            <a:lvl6pPr>
-              <a:buNone/>
-              <a:defRPr>
+            <a:lvl6pPr algn="l">
+              <a:buNone/>
+              <a:defRPr sz="1500">
                 <a:latin typeface="HarmonyOS Sans SC"/>
                 <a:ea typeface="HarmonyOS Sans SC"/>
                 <a:cs typeface="HarmonyOS Sans SC"/>
               </a:defRPr>
             </a:lvl6pPr>
-            <a:lvl7pPr>
-              <a:buNone/>
-              <a:defRPr>
+            <a:lvl7pPr algn="l">
+              <a:buNone/>
+              <a:defRPr sz="1500">
                 <a:latin typeface="HarmonyOS Sans SC"/>
                 <a:ea typeface="HarmonyOS Sans SC"/>
                 <a:cs typeface="HarmonyOS Sans SC"/>
               </a:defRPr>
             </a:lvl7pPr>
-            <a:lvl8pPr>
-              <a:buNone/>
-              <a:defRPr>
+            <a:lvl8pPr algn="l">
+              <a:buNone/>
+              <a:defRPr sz="1500">
                 <a:latin typeface="HarmonyOS Sans SC"/>
                 <a:ea typeface="HarmonyOS Sans SC"/>
                 <a:cs typeface="HarmonyOS Sans SC"/>
               </a:defRPr>
             </a:lvl8pPr>
-            <a:lvl9pPr>
-              <a:buNone/>
-              <a:defRPr>
+            <a:lvl9pPr algn="l">
+              <a:buNone/>
+              <a:defRPr sz="1500">
                 <a:latin typeface="HarmonyOS Sans SC"/>
                 <a:ea typeface="HarmonyOS Sans SC"/>
                 <a:cs typeface="HarmonyOS Sans SC"/>
@@ -4476,19 +4476,19 @@
             </a:lvl9pPr>
           </a:lstStyle>
           <a:p xmlns:a="http://schemas.openxmlformats.org/drawingml/2006/main">
-            <a:pPr>
+            <a:pPr algn="l">
               <a:lnSpc>
                 <a:spcPct val="116000"/>
               </a:lnSpc>
               <a:buNone/>
-              <a:defRPr>
+              <a:defRPr sz="1500">
                 <a:latin typeface="HarmonyOS Sans SC"/>
                 <a:ea typeface="HarmonyOS Sans SC"/>
                 <a:cs typeface="HarmonyOS Sans SC"/>
               </a:defRPr>
             </a:pPr>
             <a:r>
-              <a:rPr sz="1729" b="1" u="none" strike="noStrike">
+              <a:rPr sz="1500" b="1" u="none" strike="noStrike">
                 <a:solidFill>
                   <a:srgbClr val="65E8D4"/>
                 </a:solidFill>
@@ -4525,8 +4525,8 @@
         </p:nvSpPr>
         <p:spPr>
           <a:xfrm xmlns:a="http://schemas.openxmlformats.org/drawingml/2006/main">
-            <a:off x="609480" y="1162080"/>
-            <a:ext cx="10762920" cy="761760"/>
+            <a:off x="609600" y="1143000"/>
+            <a:ext cx="10972800" cy="838200"/>
           </a:xfrm>
           <a:prstGeom xmlns:a="http://schemas.openxmlformats.org/drawingml/2006/main" prst="rect">
             <a:avLst/>
@@ -4547,80 +4547,80 @@
             <a:noAutofit/>
           </a:bodyPr>
           <a:lstStyle xmlns:a="http://schemas.openxmlformats.org/drawingml/2006/main">
-            <a:defPPr>
-              <a:defRPr>
+            <a:defPPr algn="l">
+              <a:defRPr sz="4800">
                 <a:latin typeface="HarmonyOS Sans SC"/>
                 <a:ea typeface="HarmonyOS Sans SC"/>
                 <a:cs typeface="HarmonyOS Sans SC"/>
               </a:defRPr>
             </a:defPPr>
-            <a:lvl1pPr>
-              <a:buNone/>
-              <a:defRPr>
+            <a:lvl1pPr algn="l">
+              <a:buNone/>
+              <a:defRPr sz="4800">
                 <a:latin typeface="HarmonyOS Sans SC"/>
                 <a:ea typeface="HarmonyOS Sans SC"/>
                 <a:cs typeface="HarmonyOS Sans SC"/>
               </a:defRPr>
             </a:lvl1pPr>
-            <a:lvl2pPr>
-              <a:buNone/>
-              <a:defRPr>
+            <a:lvl2pPr algn="l">
+              <a:buNone/>
+              <a:defRPr sz="4800">
                 <a:latin typeface="HarmonyOS Sans SC"/>
                 <a:ea typeface="HarmonyOS Sans SC"/>
                 <a:cs typeface="HarmonyOS Sans SC"/>
               </a:defRPr>
             </a:lvl2pPr>
-            <a:lvl3pPr>
-              <a:buNone/>
-              <a:defRPr>
+            <a:lvl3pPr algn="l">
+              <a:buNone/>
+              <a:defRPr sz="4800">
                 <a:latin typeface="HarmonyOS Sans SC"/>
                 <a:ea typeface="HarmonyOS Sans SC"/>
                 <a:cs typeface="HarmonyOS Sans SC"/>
               </a:defRPr>
             </a:lvl3pPr>
-            <a:lvl4pPr>
-              <a:buNone/>
-              <a:defRPr>
+            <a:lvl4pPr algn="l">
+              <a:buNone/>
+              <a:defRPr sz="4800">
                 <a:latin typeface="HarmonyOS Sans SC"/>
                 <a:ea typeface="HarmonyOS Sans SC"/>
                 <a:cs typeface="HarmonyOS Sans SC"/>
               </a:defRPr>
             </a:lvl4pPr>
-            <a:lvl5pPr>
-              <a:buNone/>
-              <a:defRPr>
+            <a:lvl5pPr algn="l">
+              <a:buNone/>
+              <a:defRPr sz="4800">
                 <a:latin typeface="HarmonyOS Sans SC"/>
                 <a:ea typeface="HarmonyOS Sans SC"/>
                 <a:cs typeface="HarmonyOS Sans SC"/>
               </a:defRPr>
             </a:lvl5pPr>
-            <a:lvl6pPr>
-              <a:buNone/>
-              <a:defRPr>
+            <a:lvl6pPr algn="l">
+              <a:buNone/>
+              <a:defRPr sz="4800">
                 <a:latin typeface="HarmonyOS Sans SC"/>
                 <a:ea typeface="HarmonyOS Sans SC"/>
                 <a:cs typeface="HarmonyOS Sans SC"/>
               </a:defRPr>
             </a:lvl6pPr>
-            <a:lvl7pPr>
-              <a:buNone/>
-              <a:defRPr>
+            <a:lvl7pPr algn="l">
+              <a:buNone/>
+              <a:defRPr sz="4800">
                 <a:latin typeface="HarmonyOS Sans SC"/>
                 <a:ea typeface="HarmonyOS Sans SC"/>
                 <a:cs typeface="HarmonyOS Sans SC"/>
               </a:defRPr>
             </a:lvl7pPr>
-            <a:lvl8pPr>
-              <a:buNone/>
-              <a:defRPr>
+            <a:lvl8pPr algn="l">
+              <a:buNone/>
+              <a:defRPr sz="4800">
                 <a:latin typeface="HarmonyOS Sans SC"/>
                 <a:ea typeface="HarmonyOS Sans SC"/>
                 <a:cs typeface="HarmonyOS Sans SC"/>
               </a:defRPr>
             </a:lvl8pPr>
-            <a:lvl9pPr>
-              <a:buNone/>
-              <a:defRPr>
+            <a:lvl9pPr algn="l">
+              <a:buNone/>
+              <a:defRPr sz="4800">
                 <a:latin typeface="HarmonyOS Sans SC"/>
                 <a:ea typeface="HarmonyOS Sans SC"/>
                 <a:cs typeface="HarmonyOS Sans SC"/>
@@ -4628,19 +4628,19 @@
             </a:lvl9pPr>
           </a:lstStyle>
           <a:p xmlns:a="http://schemas.openxmlformats.org/drawingml/2006/main">
-            <a:pPr>
+            <a:pPr algn="l">
               <a:lnSpc>
                 <a:spcPct val="116000"/>
               </a:lnSpc>
               <a:buNone/>
-              <a:defRPr>
+              <a:defRPr sz="4800">
                 <a:latin typeface="HarmonyOS Sans SC"/>
                 <a:ea typeface="HarmonyOS Sans SC"/>
                 <a:cs typeface="HarmonyOS Sans SC"/>
               </a:defRPr>
             </a:pPr>
             <a:r>
-              <a:rPr sz="4650" b="1" u="none" strike="noStrike">
+              <a:rPr sz="4800" b="1" u="none" strike="noStrike">
                 <a:solidFill>
                   <a:srgbClr val="F7F7F2"/>
                 </a:solidFill>
@@ -4677,8 +4677,8 @@
         </p:nvSpPr>
         <p:spPr>
           <a:xfrm xmlns:a="http://schemas.openxmlformats.org/drawingml/2006/main">
-            <a:off x="619200" y="2124000"/>
-            <a:ext cx="10762920" cy="514080"/>
+            <a:off x="609600" y="2133600"/>
+            <a:ext cx="10972800" cy="457200"/>
           </a:xfrm>
           <a:prstGeom xmlns:a="http://schemas.openxmlformats.org/drawingml/2006/main" prst="rect">
             <a:avLst/>
@@ -4699,80 +4699,80 @@
             <a:noAutofit/>
           </a:bodyPr>
           <a:lstStyle xmlns:a="http://schemas.openxmlformats.org/drawingml/2006/main">
-            <a:defPPr>
-              <a:defRPr>
+            <a:defPPr algn="l">
+              <a:defRPr sz="2250">
                 <a:latin typeface="HarmonyOS Sans SC"/>
                 <a:ea typeface="HarmonyOS Sans SC"/>
                 <a:cs typeface="HarmonyOS Sans SC"/>
               </a:defRPr>
             </a:defPPr>
-            <a:lvl1pPr>
-              <a:buNone/>
-              <a:defRPr>
+            <a:lvl1pPr algn="l">
+              <a:buNone/>
+              <a:defRPr sz="2250">
                 <a:latin typeface="HarmonyOS Sans SC"/>
                 <a:ea typeface="HarmonyOS Sans SC"/>
                 <a:cs typeface="HarmonyOS Sans SC"/>
               </a:defRPr>
             </a:lvl1pPr>
-            <a:lvl2pPr>
-              <a:buNone/>
-              <a:defRPr>
+            <a:lvl2pPr algn="l">
+              <a:buNone/>
+              <a:defRPr sz="2250">
                 <a:latin typeface="HarmonyOS Sans SC"/>
                 <a:ea typeface="HarmonyOS Sans SC"/>
                 <a:cs typeface="HarmonyOS Sans SC"/>
               </a:defRPr>
             </a:lvl2pPr>
-            <a:lvl3pPr>
-              <a:buNone/>
-              <a:defRPr>
+            <a:lvl3pPr algn="l">
+              <a:buNone/>
+              <a:defRPr sz="2250">
                 <a:latin typeface="HarmonyOS Sans SC"/>
                 <a:ea typeface="HarmonyOS Sans SC"/>
                 <a:cs typeface="HarmonyOS Sans SC"/>
               </a:defRPr>
             </a:lvl3pPr>
-            <a:lvl4pPr>
-              <a:buNone/>
-              <a:defRPr>
+            <a:lvl4pPr algn="l">
+              <a:buNone/>
+              <a:defRPr sz="2250">
                 <a:latin typeface="HarmonyOS Sans SC"/>
                 <a:ea typeface="HarmonyOS Sans SC"/>
                 <a:cs typeface="HarmonyOS Sans SC"/>
               </a:defRPr>
             </a:lvl4pPr>
-            <a:lvl5pPr>
-              <a:buNone/>
-              <a:defRPr>
+            <a:lvl5pPr algn="l">
+              <a:buNone/>
+              <a:defRPr sz="2250">
                 <a:latin typeface="HarmonyOS Sans SC"/>
                 <a:ea typeface="HarmonyOS Sans SC"/>
                 <a:cs typeface="HarmonyOS Sans SC"/>
               </a:defRPr>
             </a:lvl5pPr>
-            <a:lvl6pPr>
-              <a:buNone/>
-              <a:defRPr>
+            <a:lvl6pPr algn="l">
+              <a:buNone/>
+              <a:defRPr sz="2250">
                 <a:latin typeface="HarmonyOS Sans SC"/>
                 <a:ea typeface="HarmonyOS Sans SC"/>
                 <a:cs typeface="HarmonyOS Sans SC"/>
               </a:defRPr>
             </a:lvl6pPr>
-            <a:lvl7pPr>
-              <a:buNone/>
-              <a:defRPr>
+            <a:lvl7pPr algn="l">
+              <a:buNone/>
+              <a:defRPr sz="2250">
                 <a:latin typeface="HarmonyOS Sans SC"/>
                 <a:ea typeface="HarmonyOS Sans SC"/>
                 <a:cs typeface="HarmonyOS Sans SC"/>
               </a:defRPr>
             </a:lvl7pPr>
-            <a:lvl8pPr>
-              <a:buNone/>
-              <a:defRPr>
+            <a:lvl8pPr algn="l">
+              <a:buNone/>
+              <a:defRPr sz="2250">
                 <a:latin typeface="HarmonyOS Sans SC"/>
                 <a:ea typeface="HarmonyOS Sans SC"/>
                 <a:cs typeface="HarmonyOS Sans SC"/>
               </a:defRPr>
             </a:lvl8pPr>
-            <a:lvl9pPr>
-              <a:buNone/>
-              <a:defRPr>
+            <a:lvl9pPr algn="l">
+              <a:buNone/>
+              <a:defRPr sz="2250">
                 <a:latin typeface="HarmonyOS Sans SC"/>
                 <a:ea typeface="HarmonyOS Sans SC"/>
                 <a:cs typeface="HarmonyOS Sans SC"/>
@@ -4780,19 +4780,19 @@
             </a:lvl9pPr>
           </a:lstStyle>
           <a:p xmlns:a="http://schemas.openxmlformats.org/drawingml/2006/main">
-            <a:pPr>
+            <a:pPr algn="l">
               <a:lnSpc>
                 <a:spcPct val="116000"/>
               </a:lnSpc>
               <a:buNone/>
-              <a:defRPr>
+              <a:defRPr sz="2250">
                 <a:latin typeface="HarmonyOS Sans SC"/>
                 <a:ea typeface="HarmonyOS Sans SC"/>
                 <a:cs typeface="HarmonyOS Sans SC"/>
               </a:defRPr>
             </a:pPr>
             <a:r>
-              <a:rPr sz="2550" b="0" u="none" strike="noStrike">
+              <a:rPr sz="2250" b="0" u="none" strike="noStrike">
                 <a:solidFill>
                   <a:srgbClr val="F7F7F2"/>
                 </a:solidFill>
@@ -4833,8 +4833,8 @@
         </p:blipFill>
         <p:spPr>
           <a:xfrm xmlns:a="http://schemas.openxmlformats.org/drawingml/2006/main">
-            <a:off x="6238800" y="3126600"/>
-            <a:ext cx="5362200" cy="2680920"/>
+            <a:off x="5276850" y="2971800"/>
+            <a:ext cx="6305550" cy="3152563"/>
           </a:xfrm>
           <a:prstGeom xmlns:a="http://schemas.openxmlformats.org/drawingml/2006/main" prst="rect">
             <a:avLst/>
@@ -4860,8 +4860,8 @@
         </p:nvSpPr>
         <p:spPr>
           <a:xfrm xmlns:a="http://schemas.openxmlformats.org/drawingml/2006/main">
-            <a:off x="628560" y="3181320"/>
-            <a:ext cx="5390640" cy="904680"/>
+            <a:off x="609600" y="2971800"/>
+            <a:ext cx="4438650" cy="990600"/>
           </a:xfrm>
           <a:prstGeom xmlns:a="http://schemas.openxmlformats.org/drawingml/2006/main" prst="rect">
             <a:avLst/>
@@ -4882,80 +4882,80 @@
             <a:noAutofit/>
           </a:bodyPr>
           <a:lstStyle xmlns:a="http://schemas.openxmlformats.org/drawingml/2006/main">
-            <a:defPPr>
-              <a:defRPr>
+            <a:defPPr algn="l">
+              <a:defRPr sz="2100">
                 <a:latin typeface="HarmonyOS Sans SC"/>
                 <a:ea typeface="HarmonyOS Sans SC"/>
                 <a:cs typeface="HarmonyOS Sans SC"/>
               </a:defRPr>
             </a:defPPr>
-            <a:lvl1pPr>
-              <a:buNone/>
-              <a:defRPr>
+            <a:lvl1pPr algn="l">
+              <a:buNone/>
+              <a:defRPr sz="2100">
                 <a:latin typeface="HarmonyOS Sans SC"/>
                 <a:ea typeface="HarmonyOS Sans SC"/>
                 <a:cs typeface="HarmonyOS Sans SC"/>
               </a:defRPr>
             </a:lvl1pPr>
-            <a:lvl2pPr>
-              <a:buNone/>
-              <a:defRPr>
+            <a:lvl2pPr algn="l">
+              <a:buNone/>
+              <a:defRPr sz="2100">
                 <a:latin typeface="HarmonyOS Sans SC"/>
                 <a:ea typeface="HarmonyOS Sans SC"/>
                 <a:cs typeface="HarmonyOS Sans SC"/>
               </a:defRPr>
             </a:lvl2pPr>
-            <a:lvl3pPr>
-              <a:buNone/>
-              <a:defRPr>
+            <a:lvl3pPr algn="l">
+              <a:buNone/>
+              <a:defRPr sz="2100">
                 <a:latin typeface="HarmonyOS Sans SC"/>
                 <a:ea typeface="HarmonyOS Sans SC"/>
                 <a:cs typeface="HarmonyOS Sans SC"/>
               </a:defRPr>
             </a:lvl3pPr>
-            <a:lvl4pPr>
-              <a:buNone/>
-              <a:defRPr>
+            <a:lvl4pPr algn="l">
+              <a:buNone/>
+              <a:defRPr sz="2100">
                 <a:latin typeface="HarmonyOS Sans SC"/>
                 <a:ea typeface="HarmonyOS Sans SC"/>
                 <a:cs typeface="HarmonyOS Sans SC"/>
               </a:defRPr>
             </a:lvl4pPr>
-            <a:lvl5pPr>
-              <a:buNone/>
-              <a:defRPr>
+            <a:lvl5pPr algn="l">
+              <a:buNone/>
+              <a:defRPr sz="2100">
                 <a:latin typeface="HarmonyOS Sans SC"/>
                 <a:ea typeface="HarmonyOS Sans SC"/>
                 <a:cs typeface="HarmonyOS Sans SC"/>
               </a:defRPr>
             </a:lvl5pPr>
-            <a:lvl6pPr>
-              <a:buNone/>
-              <a:defRPr>
+            <a:lvl6pPr algn="l">
+              <a:buNone/>
+              <a:defRPr sz="2100">
                 <a:latin typeface="HarmonyOS Sans SC"/>
                 <a:ea typeface="HarmonyOS Sans SC"/>
                 <a:cs typeface="HarmonyOS Sans SC"/>
               </a:defRPr>
             </a:lvl6pPr>
-            <a:lvl7pPr>
-              <a:buNone/>
-              <a:defRPr>
+            <a:lvl7pPr algn="l">
+              <a:buNone/>
+              <a:defRPr sz="2100">
                 <a:latin typeface="HarmonyOS Sans SC"/>
                 <a:ea typeface="HarmonyOS Sans SC"/>
                 <a:cs typeface="HarmonyOS Sans SC"/>
               </a:defRPr>
             </a:lvl7pPr>
-            <a:lvl8pPr>
-              <a:buNone/>
-              <a:defRPr>
+            <a:lvl8pPr algn="l">
+              <a:buNone/>
+              <a:defRPr sz="2100">
                 <a:latin typeface="HarmonyOS Sans SC"/>
                 <a:ea typeface="HarmonyOS Sans SC"/>
                 <a:cs typeface="HarmonyOS Sans SC"/>
               </a:defRPr>
             </a:lvl8pPr>
-            <a:lvl9pPr>
-              <a:buNone/>
-              <a:defRPr>
+            <a:lvl9pPr algn="l">
+              <a:buNone/>
+              <a:defRPr sz="2100">
                 <a:latin typeface="HarmonyOS Sans SC"/>
                 <a:ea typeface="HarmonyOS Sans SC"/>
                 <a:cs typeface="HarmonyOS Sans SC"/>
@@ -4963,19 +4963,19 @@
             </a:lvl9pPr>
           </a:lstStyle>
           <a:p xmlns:a="http://schemas.openxmlformats.org/drawingml/2006/main">
-            <a:pPr>
+            <a:pPr algn="l">
               <a:lnSpc>
                 <a:spcPct val="116000"/>
               </a:lnSpc>
               <a:buNone/>
-              <a:defRPr>
+              <a:defRPr sz="2100">
                 <a:latin typeface="HarmonyOS Sans SC"/>
                 <a:ea typeface="HarmonyOS Sans SC"/>
                 <a:cs typeface="HarmonyOS Sans SC"/>
               </a:defRPr>
             </a:pPr>
             <a:r>
-              <a:rPr sz="2250" b="0" u="none" strike="noStrike">
+              <a:rPr sz="2100" b="0" u="none" strike="noStrike">
                 <a:solidFill>
                   <a:srgbClr val="F7F7F2"/>
                 </a:solidFill>
@@ -4995,19 +4995,19 @@
             </a:endParaRPr>
           </a:p>
           <a:p xmlns:a="http://schemas.openxmlformats.org/drawingml/2006/main">
-            <a:pPr>
+            <a:pPr algn="l">
               <a:lnSpc>
                 <a:spcPct val="116000"/>
               </a:lnSpc>
               <a:buNone/>
-              <a:defRPr>
+              <a:defRPr sz="2100">
                 <a:latin typeface="HarmonyOS Sans SC"/>
                 <a:ea typeface="HarmonyOS Sans SC"/>
                 <a:cs typeface="HarmonyOS Sans SC"/>
               </a:defRPr>
             </a:pPr>
             <a:r>
-              <a:rPr sz="2250" b="0" u="none" strike="noStrike">
+              <a:rPr sz="2100" b="0" u="none" strike="noStrike">
                 <a:solidFill>
                   <a:srgbClr val="F7F7F2"/>
                 </a:solidFill>
@@ -5044,8 +5044,8 @@
         </p:nvSpPr>
         <p:spPr>
           <a:xfrm xmlns:a="http://schemas.openxmlformats.org/drawingml/2006/main">
-            <a:off x="628560" y="4448160"/>
-            <a:ext cx="5333760" cy="428400"/>
+            <a:off x="609600" y="4343400"/>
+            <a:ext cx="4438650" cy="457200"/>
           </a:xfrm>
           <a:prstGeom xmlns:a="http://schemas.openxmlformats.org/drawingml/2006/main" prst="rect">
             <a:avLst/>
@@ -5066,80 +5066,80 @@
             <a:noAutofit/>
           </a:bodyPr>
           <a:lstStyle xmlns:a="http://schemas.openxmlformats.org/drawingml/2006/main">
-            <a:defPPr>
-              <a:defRPr>
+            <a:defPPr algn="l">
+              <a:defRPr sz="2100">
                 <a:latin typeface="HarmonyOS Sans SC"/>
                 <a:ea typeface="HarmonyOS Sans SC"/>
                 <a:cs typeface="HarmonyOS Sans SC"/>
               </a:defRPr>
             </a:defPPr>
-            <a:lvl1pPr>
-              <a:buNone/>
-              <a:defRPr>
+            <a:lvl1pPr algn="l">
+              <a:buNone/>
+              <a:defRPr sz="2100">
                 <a:latin typeface="HarmonyOS Sans SC"/>
                 <a:ea typeface="HarmonyOS Sans SC"/>
                 <a:cs typeface="HarmonyOS Sans SC"/>
               </a:defRPr>
             </a:lvl1pPr>
-            <a:lvl2pPr>
-              <a:buNone/>
-              <a:defRPr>
+            <a:lvl2pPr algn="l">
+              <a:buNone/>
+              <a:defRPr sz="2100">
                 <a:latin typeface="HarmonyOS Sans SC"/>
                 <a:ea typeface="HarmonyOS Sans SC"/>
                 <a:cs typeface="HarmonyOS Sans SC"/>
               </a:defRPr>
             </a:lvl2pPr>
-            <a:lvl3pPr>
-              <a:buNone/>
-              <a:defRPr>
+            <a:lvl3pPr algn="l">
+              <a:buNone/>
+              <a:defRPr sz="2100">
                 <a:latin typeface="HarmonyOS Sans SC"/>
                 <a:ea typeface="HarmonyOS Sans SC"/>
                 <a:cs typeface="HarmonyOS Sans SC"/>
               </a:defRPr>
             </a:lvl3pPr>
-            <a:lvl4pPr>
-              <a:buNone/>
-              <a:defRPr>
+            <a:lvl4pPr algn="l">
+              <a:buNone/>
+              <a:defRPr sz="2100">
                 <a:latin typeface="HarmonyOS Sans SC"/>
                 <a:ea typeface="HarmonyOS Sans SC"/>
                 <a:cs typeface="HarmonyOS Sans SC"/>
               </a:defRPr>
             </a:lvl4pPr>
-            <a:lvl5pPr>
-              <a:buNone/>
-              <a:defRPr>
+            <a:lvl5pPr algn="l">
+              <a:buNone/>
+              <a:defRPr sz="2100">
                 <a:latin typeface="HarmonyOS Sans SC"/>
                 <a:ea typeface="HarmonyOS Sans SC"/>
                 <a:cs typeface="HarmonyOS Sans SC"/>
               </a:defRPr>
             </a:lvl5pPr>
-            <a:lvl6pPr>
-              <a:buNone/>
-              <a:defRPr>
+            <a:lvl6pPr algn="l">
+              <a:buNone/>
+              <a:defRPr sz="2100">
                 <a:latin typeface="HarmonyOS Sans SC"/>
                 <a:ea typeface="HarmonyOS Sans SC"/>
                 <a:cs typeface="HarmonyOS Sans SC"/>
               </a:defRPr>
             </a:lvl6pPr>
-            <a:lvl7pPr>
-              <a:buNone/>
-              <a:defRPr>
+            <a:lvl7pPr algn="l">
+              <a:buNone/>
+              <a:defRPr sz="2100">
                 <a:latin typeface="HarmonyOS Sans SC"/>
                 <a:ea typeface="HarmonyOS Sans SC"/>
                 <a:cs typeface="HarmonyOS Sans SC"/>
               </a:defRPr>
             </a:lvl7pPr>
-            <a:lvl8pPr>
-              <a:buNone/>
-              <a:defRPr>
+            <a:lvl8pPr algn="l">
+              <a:buNone/>
+              <a:defRPr sz="2100">
                 <a:latin typeface="HarmonyOS Sans SC"/>
                 <a:ea typeface="HarmonyOS Sans SC"/>
                 <a:cs typeface="HarmonyOS Sans SC"/>
               </a:defRPr>
             </a:lvl8pPr>
-            <a:lvl9pPr>
-              <a:buNone/>
-              <a:defRPr>
+            <a:lvl9pPr algn="l">
+              <a:buNone/>
+              <a:defRPr sz="2100">
                 <a:latin typeface="HarmonyOS Sans SC"/>
                 <a:ea typeface="HarmonyOS Sans SC"/>
                 <a:cs typeface="HarmonyOS Sans SC"/>
@@ -5147,12 +5147,12 @@
             </a:lvl9pPr>
           </a:lstStyle>
           <a:p xmlns:a="http://schemas.openxmlformats.org/drawingml/2006/main">
-            <a:pPr>
+            <a:pPr algn="l">
               <a:lnSpc>
                 <a:spcPct val="116000"/>
               </a:lnSpc>
               <a:buNone/>
-              <a:defRPr>
+              <a:defRPr sz="2100">
                 <a:latin typeface="HarmonyOS Sans SC"/>
                 <a:ea typeface="HarmonyOS Sans SC"/>
                 <a:cs typeface="HarmonyOS Sans SC"/>
@@ -5196,8 +5196,8 @@
         </p:nvSpPr>
         <p:spPr>
           <a:xfrm xmlns:a="http://schemas.openxmlformats.org/drawingml/2006/main">
-            <a:off x="628560" y="5524560"/>
-            <a:ext cx="5333760" cy="628200"/>
+            <a:off x="609600" y="5257800"/>
+            <a:ext cx="4438650" cy="762000"/>
           </a:xfrm>
           <a:prstGeom xmlns:a="http://schemas.openxmlformats.org/drawingml/2006/main" prst="rect">
             <a:avLst/>
@@ -5218,80 +5218,80 @@
             <a:noAutofit/>
           </a:bodyPr>
           <a:lstStyle xmlns:a="http://schemas.openxmlformats.org/drawingml/2006/main">
-            <a:defPPr>
-              <a:defRPr>
+            <a:defPPr algn="l">
+              <a:defRPr sz="1650">
                 <a:latin typeface="HarmonyOS Sans SC"/>
                 <a:ea typeface="HarmonyOS Sans SC"/>
                 <a:cs typeface="HarmonyOS Sans SC"/>
               </a:defRPr>
             </a:defPPr>
-            <a:lvl1pPr>
-              <a:buNone/>
-              <a:defRPr>
+            <a:lvl1pPr algn="l">
+              <a:buNone/>
+              <a:defRPr sz="1650">
                 <a:latin typeface="HarmonyOS Sans SC"/>
                 <a:ea typeface="HarmonyOS Sans SC"/>
                 <a:cs typeface="HarmonyOS Sans SC"/>
               </a:defRPr>
             </a:lvl1pPr>
-            <a:lvl2pPr>
-              <a:buNone/>
-              <a:defRPr>
+            <a:lvl2pPr algn="l">
+              <a:buNone/>
+              <a:defRPr sz="1650">
                 <a:latin typeface="HarmonyOS Sans SC"/>
                 <a:ea typeface="HarmonyOS Sans SC"/>
                 <a:cs typeface="HarmonyOS Sans SC"/>
               </a:defRPr>
             </a:lvl2pPr>
-            <a:lvl3pPr>
-              <a:buNone/>
-              <a:defRPr>
+            <a:lvl3pPr algn="l">
+              <a:buNone/>
+              <a:defRPr sz="1650">
                 <a:latin typeface="HarmonyOS Sans SC"/>
                 <a:ea typeface="HarmonyOS Sans SC"/>
                 <a:cs typeface="HarmonyOS Sans SC"/>
               </a:defRPr>
             </a:lvl3pPr>
-            <a:lvl4pPr>
-              <a:buNone/>
-              <a:defRPr>
+            <a:lvl4pPr algn="l">
+              <a:buNone/>
+              <a:defRPr sz="1650">
                 <a:latin typeface="HarmonyOS Sans SC"/>
                 <a:ea typeface="HarmonyOS Sans SC"/>
                 <a:cs typeface="HarmonyOS Sans SC"/>
               </a:defRPr>
             </a:lvl4pPr>
-            <a:lvl5pPr>
-              <a:buNone/>
-              <a:defRPr>
+            <a:lvl5pPr algn="l">
+              <a:buNone/>
+              <a:defRPr sz="1650">
                 <a:latin typeface="HarmonyOS Sans SC"/>
                 <a:ea typeface="HarmonyOS Sans SC"/>
                 <a:cs typeface="HarmonyOS Sans SC"/>
               </a:defRPr>
             </a:lvl5pPr>
-            <a:lvl6pPr>
-              <a:buNone/>
-              <a:defRPr>
+            <a:lvl6pPr algn="l">
+              <a:buNone/>
+              <a:defRPr sz="1650">
                 <a:latin typeface="HarmonyOS Sans SC"/>
                 <a:ea typeface="HarmonyOS Sans SC"/>
                 <a:cs typeface="HarmonyOS Sans SC"/>
               </a:defRPr>
             </a:lvl6pPr>
-            <a:lvl7pPr>
-              <a:buNone/>
-              <a:defRPr>
+            <a:lvl7pPr algn="l">
+              <a:buNone/>
+              <a:defRPr sz="1650">
                 <a:latin typeface="HarmonyOS Sans SC"/>
                 <a:ea typeface="HarmonyOS Sans SC"/>
                 <a:cs typeface="HarmonyOS Sans SC"/>
               </a:defRPr>
             </a:lvl7pPr>
-            <a:lvl8pPr>
-              <a:buNone/>
-              <a:defRPr>
+            <a:lvl8pPr algn="l">
+              <a:buNone/>
+              <a:defRPr sz="1650">
                 <a:latin typeface="HarmonyOS Sans SC"/>
                 <a:ea typeface="HarmonyOS Sans SC"/>
                 <a:cs typeface="HarmonyOS Sans SC"/>
               </a:defRPr>
             </a:lvl8pPr>
-            <a:lvl9pPr>
-              <a:buNone/>
-              <a:defRPr>
+            <a:lvl9pPr algn="l">
+              <a:buNone/>
+              <a:defRPr sz="1650">
                 <a:latin typeface="HarmonyOS Sans SC"/>
                 <a:ea typeface="HarmonyOS Sans SC"/>
                 <a:cs typeface="HarmonyOS Sans SC"/>
@@ -5299,19 +5299,19 @@
             </a:lvl9pPr>
           </a:lstStyle>
           <a:p xmlns:a="http://schemas.openxmlformats.org/drawingml/2006/main">
-            <a:pPr>
+            <a:pPr algn="l">
               <a:lnSpc>
                 <a:spcPct val="116000"/>
               </a:lnSpc>
               <a:buNone/>
-              <a:defRPr>
+              <a:defRPr sz="1650">
                 <a:latin typeface="HarmonyOS Sans SC"/>
                 <a:ea typeface="HarmonyOS Sans SC"/>
                 <a:cs typeface="HarmonyOS Sans SC"/>
               </a:defRPr>
             </a:pPr>
             <a:r>
-              <a:rPr sz="1800" b="0" u="none" strike="noStrike">
+              <a:rPr sz="1650" b="0" u="none" strike="noStrike">
                 <a:solidFill>
                   <a:srgbClr val="A6A7B2"/>
                 </a:solidFill>
@@ -5319,10 +5319,31 @@
                 <a:ea typeface="HarmonyOS Sans SC"/>
                 <a:cs typeface="HarmonyOS Sans SC"/>
               </a:rPr>
-              <a:t>Codex </a:t>
+              <a:t>Codex 查阅 Wiki</a:t>
             </a:r>
+            <a:endParaRPr sz="1800" b="0" u="none" strike="noStrike">
+              <a:solidFill>
+                <a:srgbClr val="FFFFFF"/>
+              </a:solidFill>
+              <a:latin typeface="Arial"/>
+              <a:ea typeface="Arial"/>
+              <a:cs typeface="Arial"/>
+            </a:endParaRPr>
+          </a:p>
+          <a:p xmlns:a="http://schemas.openxmlformats.org/drawingml/2006/main">
+            <a:pPr algn="l">
+              <a:lnSpc>
+                <a:spcPct val="116000"/>
+              </a:lnSpc>
+              <a:buNone/>
+              <a:defRPr sz="1650">
+                <a:latin typeface="HarmonyOS Sans SC"/>
+                <a:ea typeface="HarmonyOS Sans SC"/>
+                <a:cs typeface="HarmonyOS Sans SC"/>
+              </a:defRPr>
+            </a:pPr>
             <a:r>
-              <a:rPr sz="1800" b="0" u="none" strike="noStrike">
+              <a:rPr sz="1650" b="0" u="none" strike="noStrike">
                 <a:solidFill>
                   <a:srgbClr val="A6A7B2"/>
                 </a:solidFill>
@@ -5330,51 +5351,7 @@
                 <a:ea typeface="HarmonyOS Sans SC"/>
                 <a:cs typeface="HarmonyOS Sans SC"/>
               </a:rPr>
-              <a:t>查阅 </a:t>
-            </a:r>
-            <a:r>
-              <a:rPr sz="1800" b="0" u="none" strike="noStrike">
-                <a:solidFill>
-                  <a:srgbClr val="A6A7B2"/>
-                </a:solidFill>
-                <a:latin typeface="HarmonyOS Sans SC"/>
-                <a:ea typeface="HarmonyOS Sans SC"/>
-                <a:cs typeface="HarmonyOS Sans SC"/>
-              </a:rPr>
-              <a:t>Wiki</a:t>
-            </a:r>
-            <a:r>
-              <a:rPr sz="1800" b="0" u="none" strike="noStrike">
-                <a:solidFill>
-                  <a:srgbClr val="A6A7B2"/>
-                </a:solidFill>
-                <a:latin typeface="HarmonyOS Sans SC"/>
-                <a:ea typeface="HarmonyOS Sans SC"/>
-                <a:cs typeface="HarmonyOS Sans SC"/>
-              </a:rPr>
-              <a:t>，依据 </a:t>
-            </a:r>
-            <a:r>
-              <a:rPr sz="1800" b="0" u="none" strike="noStrike">
-                <a:solidFill>
-                  <a:srgbClr val="A6A7B2"/>
-                </a:solidFill>
-                <a:latin typeface="HarmonyOS Sans SC"/>
-                <a:ea typeface="HarmonyOS Sans SC"/>
-                <a:cs typeface="HarmonyOS Sans SC"/>
-              </a:rPr>
-              <a:t>Python API </a:t>
-            </a:r>
-            <a:r>
-              <a:rPr sz="1800" b="0" u="none" strike="noStrike">
-                <a:solidFill>
-                  <a:srgbClr val="A6A7B2"/>
-                </a:solidFill>
-                <a:latin typeface="HarmonyOS Sans SC"/>
-                <a:ea typeface="HarmonyOS Sans SC"/>
-                <a:cs typeface="HarmonyOS Sans SC"/>
-              </a:rPr>
-              <a:t>实现</a:t>
+              <a:t>依据 Python API 实现</a:t>
             </a:r>
             <a:endParaRPr sz="1800" b="0" u="none" strike="noStrike">
               <a:solidFill>
@@ -5413,8 +5390,8 @@
         </p:blipFill>
         <p:spPr>
           <a:xfrm xmlns:a="http://schemas.openxmlformats.org/drawingml/2006/main">
-            <a:off x="609600" y="6524625"/>
-            <a:ext cx="1952625" cy="228220"/>
+            <a:off x="609600" y="6400800"/>
+            <a:ext cx="1952625" cy="228219"/>
           </a:xfrm>
           <a:prstGeom xmlns:a="http://schemas.openxmlformats.org/drawingml/2006/main" prst="rect">
             <a:avLst/>
@@ -5437,8 +5414,8 @@
         </p:nvSpPr>
         <p:spPr>
           <a:xfrm xmlns:a="http://schemas.openxmlformats.org/drawingml/2006/main">
-            <a:off x="11191875" y="6505575"/>
-            <a:ext cx="419100" cy="247650"/>
+            <a:off x="11163300" y="6400800"/>
+            <a:ext cx="419100" cy="228600"/>
           </a:xfrm>
           <a:prstGeom xmlns:a="http://schemas.openxmlformats.org/drawingml/2006/main" prst="rect">
             <a:avLst/>

</xml_diff>